<commit_message>
remapped indices (might be wrong, though) in data.yaml
</commit_message>
<xml_diff>
--- a/presentation.pptx
+++ b/presentation.pptx
@@ -111,6 +111,11 @@
       </a:defRPr>
     </a:lvl9pPr>
   </p:defaultTextStyle>
+  <p:extLst>
+    <p:ext uri="{EFAFB233-063F-42B5-8137-9DF3F51BA10A}">
+      <p15:sldGuideLst xmlns:p15="http://schemas.microsoft.com/office/powerpoint/2012/main"/>
+    </p:ext>
+  </p:extLst>
 </p:presentation>
 </file>
 
@@ -375,7 +380,7 @@
           <a:p>
             <a:fld id="{9E7B9DCE-2806-D243-A137-B4C1362D6AA1}" type="datetimeFigureOut">
               <a:rPr lang="en-GB" smtClean="0"/>
-              <a:t>30/11/2025</a:t>
+              <a:t>01/12/2025</a:t>
             </a:fld>
             <a:endParaRPr lang="en-GB"/>
           </a:p>
@@ -575,7 +580,7 @@
           <a:p>
             <a:fld id="{9E7B9DCE-2806-D243-A137-B4C1362D6AA1}" type="datetimeFigureOut">
               <a:rPr lang="en-GB" smtClean="0"/>
-              <a:t>30/11/2025</a:t>
+              <a:t>01/12/2025</a:t>
             </a:fld>
             <a:endParaRPr lang="en-GB"/>
           </a:p>
@@ -785,7 +790,7 @@
           <a:p>
             <a:fld id="{9E7B9DCE-2806-D243-A137-B4C1362D6AA1}" type="datetimeFigureOut">
               <a:rPr lang="en-GB" smtClean="0"/>
-              <a:t>30/11/2025</a:t>
+              <a:t>01/12/2025</a:t>
             </a:fld>
             <a:endParaRPr lang="en-GB"/>
           </a:p>
@@ -985,7 +990,7 @@
           <a:p>
             <a:fld id="{9E7B9DCE-2806-D243-A137-B4C1362D6AA1}" type="datetimeFigureOut">
               <a:rPr lang="en-GB" smtClean="0"/>
-              <a:t>30/11/2025</a:t>
+              <a:t>01/12/2025</a:t>
             </a:fld>
             <a:endParaRPr lang="en-GB"/>
           </a:p>
@@ -1261,7 +1266,7 @@
           <a:p>
             <a:fld id="{9E7B9DCE-2806-D243-A137-B4C1362D6AA1}" type="datetimeFigureOut">
               <a:rPr lang="en-GB" smtClean="0"/>
-              <a:t>30/11/2025</a:t>
+              <a:t>01/12/2025</a:t>
             </a:fld>
             <a:endParaRPr lang="en-GB"/>
           </a:p>
@@ -1529,7 +1534,7 @@
           <a:p>
             <a:fld id="{9E7B9DCE-2806-D243-A137-B4C1362D6AA1}" type="datetimeFigureOut">
               <a:rPr lang="en-GB" smtClean="0"/>
-              <a:t>30/11/2025</a:t>
+              <a:t>01/12/2025</a:t>
             </a:fld>
             <a:endParaRPr lang="en-GB"/>
           </a:p>
@@ -1944,7 +1949,7 @@
           <a:p>
             <a:fld id="{9E7B9DCE-2806-D243-A137-B4C1362D6AA1}" type="datetimeFigureOut">
               <a:rPr lang="en-GB" smtClean="0"/>
-              <a:t>30/11/2025</a:t>
+              <a:t>01/12/2025</a:t>
             </a:fld>
             <a:endParaRPr lang="en-GB"/>
           </a:p>
@@ -2086,7 +2091,7 @@
           <a:p>
             <a:fld id="{9E7B9DCE-2806-D243-A137-B4C1362D6AA1}" type="datetimeFigureOut">
               <a:rPr lang="en-GB" smtClean="0"/>
-              <a:t>30/11/2025</a:t>
+              <a:t>01/12/2025</a:t>
             </a:fld>
             <a:endParaRPr lang="en-GB"/>
           </a:p>
@@ -2199,7 +2204,7 @@
           <a:p>
             <a:fld id="{9E7B9DCE-2806-D243-A137-B4C1362D6AA1}" type="datetimeFigureOut">
               <a:rPr lang="en-GB" smtClean="0"/>
-              <a:t>30/11/2025</a:t>
+              <a:t>01/12/2025</a:t>
             </a:fld>
             <a:endParaRPr lang="en-GB"/>
           </a:p>
@@ -2512,7 +2517,7 @@
           <a:p>
             <a:fld id="{9E7B9DCE-2806-D243-A137-B4C1362D6AA1}" type="datetimeFigureOut">
               <a:rPr lang="en-GB" smtClean="0"/>
-              <a:t>30/11/2025</a:t>
+              <a:t>01/12/2025</a:t>
             </a:fld>
             <a:endParaRPr lang="en-GB"/>
           </a:p>
@@ -2801,7 +2806,7 @@
           <a:p>
             <a:fld id="{9E7B9DCE-2806-D243-A137-B4C1362D6AA1}" type="datetimeFigureOut">
               <a:rPr lang="en-GB" smtClean="0"/>
-              <a:t>30/11/2025</a:t>
+              <a:t>01/12/2025</a:t>
             </a:fld>
             <a:endParaRPr lang="en-GB"/>
           </a:p>
@@ -3044,7 +3049,7 @@
           <a:p>
             <a:fld id="{9E7B9DCE-2806-D243-A137-B4C1362D6AA1}" type="datetimeFigureOut">
               <a:rPr lang="en-GB" smtClean="0"/>
-              <a:t>30/11/2025</a:t>
+              <a:t>01/12/2025</a:t>
             </a:fld>
             <a:endParaRPr lang="en-GB"/>
           </a:p>
@@ -13390,8 +13395,8 @@
           </a:p>
         </p:txBody>
       </p:sp>
-      <mc:AlternateContent xmlns:mc="http://schemas.openxmlformats.org/markup-compatibility/2006">
-        <mc:Choice xmlns:p14="http://schemas.microsoft.com/office/powerpoint/2010/main" Requires="p14">
+      <mc:AlternateContent xmlns:mc="http://schemas.openxmlformats.org/markup-compatibility/2006" xmlns:p14="http://schemas.microsoft.com/office/powerpoint/2010/main">
+        <mc:Choice Requires="p14">
           <p:contentPart p14:bwMode="auto" r:id="rId3">
             <p14:nvContentPartPr>
               <p14:cNvPr id="7" name="Freihand 6">
@@ -13410,7 +13415,7 @@
             </p14:xfrm>
           </p:contentPart>
         </mc:Choice>
-        <mc:Fallback>
+        <mc:Fallback xmlns="">
           <p:pic>
             <p:nvPicPr>
               <p:cNvPr id="7" name="Freihand 6">
@@ -13485,8 +13490,8 @@
           </a:p>
         </p:txBody>
       </p:sp>
-      <mc:AlternateContent xmlns:mc="http://schemas.openxmlformats.org/markup-compatibility/2006">
-        <mc:Choice xmlns:p14="http://schemas.microsoft.com/office/powerpoint/2010/main" Requires="p14">
+      <mc:AlternateContent xmlns:mc="http://schemas.openxmlformats.org/markup-compatibility/2006" xmlns:p14="http://schemas.microsoft.com/office/powerpoint/2010/main">
+        <mc:Choice Requires="p14">
           <p:contentPart p14:bwMode="auto" r:id="rId6">
             <p14:nvContentPartPr>
               <p14:cNvPr id="12" name="Freihand 11">
@@ -13505,7 +13510,7 @@
             </p14:xfrm>
           </p:contentPart>
         </mc:Choice>
-        <mc:Fallback>
+        <mc:Fallback xmlns="">
           <p:pic>
             <p:nvPicPr>
               <p:cNvPr id="12" name="Freihand 11">
@@ -13536,8 +13541,8 @@
           </p:pic>
         </mc:Fallback>
       </mc:AlternateContent>
-      <mc:AlternateContent xmlns:mc="http://schemas.openxmlformats.org/markup-compatibility/2006">
-        <mc:Choice xmlns:p14="http://schemas.microsoft.com/office/powerpoint/2010/main" Requires="p14">
+      <mc:AlternateContent xmlns:mc="http://schemas.openxmlformats.org/markup-compatibility/2006" xmlns:p14="http://schemas.microsoft.com/office/powerpoint/2010/main">
+        <mc:Choice Requires="p14">
           <p:contentPart p14:bwMode="auto" r:id="rId8">
             <p14:nvContentPartPr>
               <p14:cNvPr id="16" name="Freihand 15">
@@ -13556,7 +13561,7 @@
             </p14:xfrm>
           </p:contentPart>
         </mc:Choice>
-        <mc:Fallback>
+        <mc:Fallback xmlns="">
           <p:pic>
             <p:nvPicPr>
               <p:cNvPr id="16" name="Freihand 15">
@@ -13587,8 +13592,8 @@
           </p:pic>
         </mc:Fallback>
       </mc:AlternateContent>
-      <mc:AlternateContent xmlns:mc="http://schemas.openxmlformats.org/markup-compatibility/2006">
-        <mc:Choice xmlns:p14="http://schemas.microsoft.com/office/powerpoint/2010/main" Requires="p14">
+      <mc:AlternateContent xmlns:mc="http://schemas.openxmlformats.org/markup-compatibility/2006" xmlns:p14="http://schemas.microsoft.com/office/powerpoint/2010/main">
+        <mc:Choice Requires="p14">
           <p:contentPart p14:bwMode="auto" r:id="rId10">
             <p14:nvContentPartPr>
               <p14:cNvPr id="21" name="Freihand 20">
@@ -13607,7 +13612,7 @@
             </p14:xfrm>
           </p:contentPart>
         </mc:Choice>
-        <mc:Fallback>
+        <mc:Fallback xmlns="">
           <p:pic>
             <p:nvPicPr>
               <p:cNvPr id="21" name="Freihand 20">
@@ -13700,6 +13705,41 @@
             <a:r>
               <a:rPr lang="en-GB" dirty="0"/>
               <a:t>ETH Zürich, Foggy driving, 101 real world images</a:t>
+            </a:r>
+          </a:p>
+        </p:txBody>
+      </p:sp>
+      <p:sp>
+        <p:nvSpPr>
+          <p:cNvPr id="2" name="Textfeld 1">
+            <a:extLst>
+              <a:ext uri="{FF2B5EF4-FFF2-40B4-BE49-F238E27FC236}">
+                <a16:creationId xmlns:a16="http://schemas.microsoft.com/office/drawing/2014/main" id="{B15BFF0B-D470-AD70-644C-10EF4E603BCC}"/>
+              </a:ext>
+            </a:extLst>
+          </p:cNvPr>
+          <p:cNvSpPr txBox="1"/>
+          <p:nvPr/>
+        </p:nvSpPr>
+        <p:spPr>
+          <a:xfrm>
+            <a:off x="1643063" y="5657850"/>
+            <a:ext cx="4605300" cy="369332"/>
+          </a:xfrm>
+          <a:prstGeom prst="rect">
+            <a:avLst/>
+          </a:prstGeom>
+          <a:noFill/>
+        </p:spPr>
+        <p:txBody>
+          <a:bodyPr wrap="none" rtlCol="0">
+            <a:spAutoFit/>
+          </a:bodyPr>
+          <a:lstStyle/>
+          <a:p>
+            <a:r>
+              <a:rPr lang="en-GB" dirty="0"/>
+              <a:t>DAWN:  303 foggy images with bounding boxes</a:t>
             </a:r>
           </a:p>
         </p:txBody>

</xml_diff>

<commit_message>
more dataset images for slides
</commit_message>
<xml_diff>
--- a/presentation.pptx
+++ b/presentation.pptx
@@ -380,7 +380,7 @@
           <a:p>
             <a:fld id="{9E7B9DCE-2806-D243-A137-B4C1362D6AA1}" type="datetimeFigureOut">
               <a:rPr lang="en-GB" smtClean="0"/>
-              <a:t>01/12/2025</a:t>
+              <a:t>03/12/2025</a:t>
             </a:fld>
             <a:endParaRPr lang="en-GB"/>
           </a:p>
@@ -580,7 +580,7 @@
           <a:p>
             <a:fld id="{9E7B9DCE-2806-D243-A137-B4C1362D6AA1}" type="datetimeFigureOut">
               <a:rPr lang="en-GB" smtClean="0"/>
-              <a:t>01/12/2025</a:t>
+              <a:t>03/12/2025</a:t>
             </a:fld>
             <a:endParaRPr lang="en-GB"/>
           </a:p>
@@ -790,7 +790,7 @@
           <a:p>
             <a:fld id="{9E7B9DCE-2806-D243-A137-B4C1362D6AA1}" type="datetimeFigureOut">
               <a:rPr lang="en-GB" smtClean="0"/>
-              <a:t>01/12/2025</a:t>
+              <a:t>03/12/2025</a:t>
             </a:fld>
             <a:endParaRPr lang="en-GB"/>
           </a:p>
@@ -990,7 +990,7 @@
           <a:p>
             <a:fld id="{9E7B9DCE-2806-D243-A137-B4C1362D6AA1}" type="datetimeFigureOut">
               <a:rPr lang="en-GB" smtClean="0"/>
-              <a:t>01/12/2025</a:t>
+              <a:t>03/12/2025</a:t>
             </a:fld>
             <a:endParaRPr lang="en-GB"/>
           </a:p>
@@ -1266,7 +1266,7 @@
           <a:p>
             <a:fld id="{9E7B9DCE-2806-D243-A137-B4C1362D6AA1}" type="datetimeFigureOut">
               <a:rPr lang="en-GB" smtClean="0"/>
-              <a:t>01/12/2025</a:t>
+              <a:t>03/12/2025</a:t>
             </a:fld>
             <a:endParaRPr lang="en-GB"/>
           </a:p>
@@ -1534,7 +1534,7 @@
           <a:p>
             <a:fld id="{9E7B9DCE-2806-D243-A137-B4C1362D6AA1}" type="datetimeFigureOut">
               <a:rPr lang="en-GB" smtClean="0"/>
-              <a:t>01/12/2025</a:t>
+              <a:t>03/12/2025</a:t>
             </a:fld>
             <a:endParaRPr lang="en-GB"/>
           </a:p>
@@ -1949,7 +1949,7 @@
           <a:p>
             <a:fld id="{9E7B9DCE-2806-D243-A137-B4C1362D6AA1}" type="datetimeFigureOut">
               <a:rPr lang="en-GB" smtClean="0"/>
-              <a:t>01/12/2025</a:t>
+              <a:t>03/12/2025</a:t>
             </a:fld>
             <a:endParaRPr lang="en-GB"/>
           </a:p>
@@ -2091,7 +2091,7 @@
           <a:p>
             <a:fld id="{9E7B9DCE-2806-D243-A137-B4C1362D6AA1}" type="datetimeFigureOut">
               <a:rPr lang="en-GB" smtClean="0"/>
-              <a:t>01/12/2025</a:t>
+              <a:t>03/12/2025</a:t>
             </a:fld>
             <a:endParaRPr lang="en-GB"/>
           </a:p>
@@ -2204,7 +2204,7 @@
           <a:p>
             <a:fld id="{9E7B9DCE-2806-D243-A137-B4C1362D6AA1}" type="datetimeFigureOut">
               <a:rPr lang="en-GB" smtClean="0"/>
-              <a:t>01/12/2025</a:t>
+              <a:t>03/12/2025</a:t>
             </a:fld>
             <a:endParaRPr lang="en-GB"/>
           </a:p>
@@ -2517,7 +2517,7 @@
           <a:p>
             <a:fld id="{9E7B9DCE-2806-D243-A137-B4C1362D6AA1}" type="datetimeFigureOut">
               <a:rPr lang="en-GB" smtClean="0"/>
-              <a:t>01/12/2025</a:t>
+              <a:t>03/12/2025</a:t>
             </a:fld>
             <a:endParaRPr lang="en-GB"/>
           </a:p>
@@ -2806,7 +2806,7 @@
           <a:p>
             <a:fld id="{9E7B9DCE-2806-D243-A137-B4C1362D6AA1}" type="datetimeFigureOut">
               <a:rPr lang="en-GB" smtClean="0"/>
-              <a:t>01/12/2025</a:t>
+              <a:t>03/12/2025</a:t>
             </a:fld>
             <a:endParaRPr lang="en-GB"/>
           </a:p>
@@ -3049,7 +3049,7 @@
           <a:p>
             <a:fld id="{9E7B9DCE-2806-D243-A137-B4C1362D6AA1}" type="datetimeFigureOut">
               <a:rPr lang="en-GB" smtClean="0"/>
-              <a:t>01/12/2025</a:t>
+              <a:t>03/12/2025</a:t>
             </a:fld>
             <a:endParaRPr lang="en-GB"/>
           </a:p>
@@ -13816,10 +13816,10 @@
         </p:nvGrpSpPr>
         <p:grpSpPr>
           <a:xfrm>
-            <a:off x="523406" y="1702478"/>
-            <a:ext cx="3835399" cy="2335572"/>
-            <a:chOff x="598357" y="1733256"/>
-            <a:chExt cx="3835399" cy="2335572"/>
+            <a:off x="523405" y="1759567"/>
+            <a:ext cx="3673516" cy="2278483"/>
+            <a:chOff x="598356" y="1790345"/>
+            <a:chExt cx="3673516" cy="2278483"/>
           </a:xfrm>
         </p:grpSpPr>
         <p:pic>
@@ -13866,8 +13866,8 @@
           </p:nvSpPr>
           <p:spPr>
             <a:xfrm>
-              <a:off x="598357" y="1733256"/>
-              <a:ext cx="3835399" cy="338554"/>
+              <a:off x="598356" y="1790345"/>
+              <a:ext cx="3673515" cy="307777"/>
             </a:xfrm>
             <a:prstGeom prst="rect">
               <a:avLst/>
@@ -13881,8 +13881,8 @@
             <a:lstStyle/>
             <a:p>
               <a:r>
-                <a:rPr lang="en-GB" sz="1600" b="1" dirty="0"/>
-                <a:t>Foggy Cityscape Images [1] (3475 images)</a:t>
+                <a:rPr lang="en-GB" sz="1400" b="1" dirty="0"/>
+                <a:t>Foggy Cityscape Images [1] (2976 + 501 images)</a:t>
               </a:r>
             </a:p>
           </p:txBody>
@@ -13902,8 +13902,8 @@
         </p:nvSpPr>
         <p:spPr>
           <a:xfrm>
-            <a:off x="-24240" y="6596390"/>
-            <a:ext cx="4985660" cy="261610"/>
+            <a:off x="0" y="6474940"/>
+            <a:ext cx="5264583" cy="430887"/>
           </a:xfrm>
           <a:prstGeom prst="rect">
             <a:avLst/>
@@ -13918,23 +13918,92 @@
           <a:p>
             <a:r>
               <a:rPr lang="en-GB" sz="1100" dirty="0"/>
-              <a:t>[1] https://</a:t>
+              <a:t>[1] </a:t>
             </a:r>
             <a:r>
-              <a:rPr lang="en-GB" sz="1100" dirty="0" err="1"/>
-              <a:t>www.kaggle.com</a:t>
+              <a:rPr lang="en-GB" sz="1100" dirty="0">
+                <a:hlinkClick r:id="rId3"/>
+              </a:rPr>
+              <a:t>https://www.kaggle.com/datasets/khitdon/foggy-cityscapes-yolo</a:t>
+            </a:r>
+            <a:br>
+              <a:rPr lang="en-GB" sz="1100" dirty="0"/>
+            </a:br>
+            <a:r>
+              <a:rPr lang="en-GB" sz="1100" dirty="0"/>
+              <a:t>[2] </a:t>
             </a:r>
             <a:r>
-              <a:rPr lang="en-GB" sz="1100" dirty="0"/>
-              <a:t>/datasets/</a:t>
+              <a:rPr lang="en-GB" sz="1100" dirty="0">
+                <a:hlinkClick r:id="rId4"/>
+              </a:rPr>
+              <a:t>https://www.kaggle.com/datasets/orvile/dawn-detection-in-adverse-weather-nature</a:t>
             </a:r>
+            <a:endParaRPr lang="en-GB" sz="1100" dirty="0"/>
+          </a:p>
+        </p:txBody>
+      </p:sp>
+      <p:pic>
+        <p:nvPicPr>
+          <p:cNvPr id="5" name="Grafik 4">
+            <a:extLst>
+              <a:ext uri="{FF2B5EF4-FFF2-40B4-BE49-F238E27FC236}">
+                <a16:creationId xmlns:a16="http://schemas.microsoft.com/office/drawing/2014/main" id="{E184B02E-E1B9-6148-D47B-702E7BD8697F}"/>
+              </a:ext>
+            </a:extLst>
+          </p:cNvPr>
+          <p:cNvPicPr>
+            <a:picLocks noChangeAspect="1"/>
+          </p:cNvPicPr>
+          <p:nvPr/>
+        </p:nvPicPr>
+        <p:blipFill>
+          <a:blip r:embed="rId5"/>
+          <a:stretch>
+            <a:fillRect/>
+          </a:stretch>
+        </p:blipFill>
+        <p:spPr>
+          <a:xfrm>
+            <a:off x="523405" y="4364814"/>
+            <a:ext cx="3673515" cy="2008808"/>
+          </a:xfrm>
+          <a:prstGeom prst="rect">
+            <a:avLst/>
+          </a:prstGeom>
+        </p:spPr>
+      </p:pic>
+      <p:sp>
+        <p:nvSpPr>
+          <p:cNvPr id="7" name="Textfeld 6">
+            <a:extLst>
+              <a:ext uri="{FF2B5EF4-FFF2-40B4-BE49-F238E27FC236}">
+                <a16:creationId xmlns:a16="http://schemas.microsoft.com/office/drawing/2014/main" id="{6071C3DD-867C-D1CC-03EE-F2A9D888644E}"/>
+              </a:ext>
+            </a:extLst>
+          </p:cNvPr>
+          <p:cNvSpPr txBox="1"/>
+          <p:nvPr/>
+        </p:nvSpPr>
+        <p:spPr>
+          <a:xfrm>
+            <a:off x="912092" y="4106929"/>
+            <a:ext cx="3835399" cy="307777"/>
+          </a:xfrm>
+          <a:prstGeom prst="rect">
+            <a:avLst/>
+          </a:prstGeom>
+          <a:noFill/>
+        </p:spPr>
+        <p:txBody>
+          <a:bodyPr wrap="square" rtlCol="0">
+            <a:spAutoFit/>
+          </a:bodyPr>
+          <a:lstStyle/>
+          <a:p>
             <a:r>
-              <a:rPr lang="en-GB" sz="1100" dirty="0" err="1"/>
-              <a:t>yessicatuteja</a:t>
-            </a:r>
-            <a:r>
-              <a:rPr lang="en-GB" sz="1100" dirty="0"/>
-              <a:t>/foggy-cityscapes-image-dataset</a:t>
+              <a:rPr lang="en-GB" sz="1400" b="1" dirty="0"/>
+              <a:t>DAWN Images [2] (301 + 167 images)</a:t>
             </a:r>
           </a:p>
         </p:txBody>

</xml_diff>